<commit_message>
fix: remove hardcoded language from Office templates
Strip Western-language metadata (en-US, en-GB, it-IT, fr-FR) from
empty.docx, empty.xlsx, empty.pptx, and empty.ods templates so that
the spellcheck language falls back to the user's locale passed via
Collabora Online's &lang= URL parameter.

Fixes: docx/xlsx/pptx/ods files created in Files defaulting to
English spellcheck regardless of user locale setting.

Co-Authored-By: Claude Opus 4.6 <noreply@anthropic.com>
</commit_message>
<xml_diff>
--- a/core/src/main/resources/templates/empty.pptx
+++ b/core/src/main/resources/templates/empty.pptx
@@ -84,7 +84,7 @@
           <a:bodyPr/>
           <a:p>
             <a:r>
-              <a:rPr lang="en-US"/>
+              <a:rPr/>
               <a:t/>
             </a:r>
           </a:p>
@@ -140,7 +140,7 @@
             <a:noAutofit/>
           </a:bodyPr>
           <a:p>
-            <a:endParaRPr b="0" lang="it-IT" sz="1800" spc="-1" strike="noStrike">
+            <a:endParaRPr b="0" sz="1800" spc="-1" strike="noStrike">
               <a:solidFill>
                 <a:srgbClr val="000000"/>
               </a:solidFill>
@@ -186,7 +186,7 @@
               </a:spcBef>
               <a:buNone/>
             </a:pPr>
-            <a:endParaRPr b="0" lang="it-IT" sz="2800" spc="-1" strike="noStrike">
+            <a:endParaRPr b="0" sz="2800" spc="-1" strike="noStrike">
               <a:solidFill>
                 <a:srgbClr val="000000"/>
               </a:solidFill>
@@ -232,7 +232,7 @@
               </a:spcBef>
               <a:buNone/>
             </a:pPr>
-            <a:endParaRPr b="0" lang="it-IT" sz="2800" spc="-1" strike="noStrike">
+            <a:endParaRPr b="0" sz="2800" spc="-1" strike="noStrike">
               <a:solidFill>
                 <a:srgbClr val="000000"/>
               </a:solidFill>
@@ -296,7 +296,7 @@
           <a:bodyPr/>
           <a:p>
             <a:r>
-              <a:rPr lang="en-US"/>
+              <a:rPr/>
               <a:t/>
             </a:r>
           </a:p>
@@ -352,7 +352,7 @@
             <a:noAutofit/>
           </a:bodyPr>
           <a:p>
-            <a:endParaRPr b="0" lang="it-IT" sz="1800" spc="-1" strike="noStrike">
+            <a:endParaRPr b="0" sz="1800" spc="-1" strike="noStrike">
               <a:solidFill>
                 <a:srgbClr val="000000"/>
               </a:solidFill>
@@ -398,7 +398,7 @@
               </a:spcBef>
               <a:buNone/>
             </a:pPr>
-            <a:endParaRPr b="0" lang="it-IT" sz="2800" spc="-1" strike="noStrike">
+            <a:endParaRPr b="0" sz="2800" spc="-1" strike="noStrike">
               <a:solidFill>
                 <a:srgbClr val="000000"/>
               </a:solidFill>
@@ -444,7 +444,7 @@
               </a:spcBef>
               <a:buNone/>
             </a:pPr>
-            <a:endParaRPr b="0" lang="it-IT" sz="2800" spc="-1" strike="noStrike">
+            <a:endParaRPr b="0" sz="2800" spc="-1" strike="noStrike">
               <a:solidFill>
                 <a:srgbClr val="000000"/>
               </a:solidFill>
@@ -490,7 +490,7 @@
               </a:spcBef>
               <a:buNone/>
             </a:pPr>
-            <a:endParaRPr b="0" lang="it-IT" sz="2800" spc="-1" strike="noStrike">
+            <a:endParaRPr b="0" sz="2800" spc="-1" strike="noStrike">
               <a:solidFill>
                 <a:srgbClr val="000000"/>
               </a:solidFill>
@@ -536,7 +536,7 @@
               </a:spcBef>
               <a:buNone/>
             </a:pPr>
-            <a:endParaRPr b="0" lang="it-IT" sz="2800" spc="-1" strike="noStrike">
+            <a:endParaRPr b="0" sz="2800" spc="-1" strike="noStrike">
               <a:solidFill>
                 <a:srgbClr val="000000"/>
               </a:solidFill>
@@ -600,7 +600,7 @@
           <a:bodyPr/>
           <a:p>
             <a:r>
-              <a:rPr lang="en-US"/>
+              <a:rPr/>
               <a:t/>
             </a:r>
           </a:p>
@@ -656,7 +656,7 @@
             <a:noAutofit/>
           </a:bodyPr>
           <a:p>
-            <a:endParaRPr b="0" lang="it-IT" sz="1800" spc="-1" strike="noStrike">
+            <a:endParaRPr b="0" sz="1800" spc="-1" strike="noStrike">
               <a:solidFill>
                 <a:srgbClr val="000000"/>
               </a:solidFill>
@@ -702,7 +702,7 @@
               </a:spcBef>
               <a:buNone/>
             </a:pPr>
-            <a:endParaRPr b="0" lang="it-IT" sz="2800" spc="-1" strike="noStrike">
+            <a:endParaRPr b="0" sz="2800" spc="-1" strike="noStrike">
               <a:solidFill>
                 <a:srgbClr val="000000"/>
               </a:solidFill>
@@ -748,7 +748,7 @@
               </a:spcBef>
               <a:buNone/>
             </a:pPr>
-            <a:endParaRPr b="0" lang="it-IT" sz="2800" spc="-1" strike="noStrike">
+            <a:endParaRPr b="0" sz="2800" spc="-1" strike="noStrike">
               <a:solidFill>
                 <a:srgbClr val="000000"/>
               </a:solidFill>
@@ -794,7 +794,7 @@
               </a:spcBef>
               <a:buNone/>
             </a:pPr>
-            <a:endParaRPr b="0" lang="it-IT" sz="2800" spc="-1" strike="noStrike">
+            <a:endParaRPr b="0" sz="2800" spc="-1" strike="noStrike">
               <a:solidFill>
                 <a:srgbClr val="000000"/>
               </a:solidFill>
@@ -840,7 +840,7 @@
               </a:spcBef>
               <a:buNone/>
             </a:pPr>
-            <a:endParaRPr b="0" lang="it-IT" sz="2800" spc="-1" strike="noStrike">
+            <a:endParaRPr b="0" sz="2800" spc="-1" strike="noStrike">
               <a:solidFill>
                 <a:srgbClr val="000000"/>
               </a:solidFill>
@@ -886,7 +886,7 @@
               </a:spcBef>
               <a:buNone/>
             </a:pPr>
-            <a:endParaRPr b="0" lang="it-IT" sz="2800" spc="-1" strike="noStrike">
+            <a:endParaRPr b="0" sz="2800" spc="-1" strike="noStrike">
               <a:solidFill>
                 <a:srgbClr val="000000"/>
               </a:solidFill>
@@ -932,7 +932,7 @@
               </a:spcBef>
               <a:buNone/>
             </a:pPr>
-            <a:endParaRPr b="0" lang="it-IT" sz="2800" spc="-1" strike="noStrike">
+            <a:endParaRPr b="0" sz="2800" spc="-1" strike="noStrike">
               <a:solidFill>
                 <a:srgbClr val="000000"/>
               </a:solidFill>
@@ -996,7 +996,7 @@
           <a:bodyPr/>
           <a:p>
             <a:r>
-              <a:rPr lang="en-US"/>
+              <a:rPr/>
               <a:t/>
             </a:r>
           </a:p>
@@ -1052,7 +1052,7 @@
             <a:noAutofit/>
           </a:bodyPr>
           <a:p>
-            <a:endParaRPr b="0" lang="it-IT" sz="1800" spc="-1" strike="noStrike">
+            <a:endParaRPr b="0" sz="1800" spc="-1" strike="noStrike">
               <a:solidFill>
                 <a:srgbClr val="000000"/>
               </a:solidFill>
@@ -1092,7 +1092,7 @@
             <a:pPr algn="ctr">
               <a:buNone/>
             </a:pPr>
-            <a:endParaRPr b="0" lang="en-US" sz="3200" spc="-1" strike="noStrike">
+            <a:endParaRPr b="0" sz="3200" spc="-1" strike="noStrike">
               <a:latin typeface="Arial"/>
             </a:endParaRPr>
           </a:p>
@@ -1153,7 +1153,7 @@
           <a:bodyPr/>
           <a:p>
             <a:r>
-              <a:rPr lang="en-US"/>
+              <a:rPr/>
               <a:t/>
             </a:r>
           </a:p>
@@ -1209,7 +1209,7 @@
             <a:noAutofit/>
           </a:bodyPr>
           <a:p>
-            <a:endParaRPr b="0" lang="it-IT" sz="1800" spc="-1" strike="noStrike">
+            <a:endParaRPr b="0" sz="1800" spc="-1" strike="noStrike">
               <a:solidFill>
                 <a:srgbClr val="000000"/>
               </a:solidFill>
@@ -1255,7 +1255,7 @@
               </a:spcBef>
               <a:buNone/>
             </a:pPr>
-            <a:endParaRPr b="0" lang="it-IT" sz="2800" spc="-1" strike="noStrike">
+            <a:endParaRPr b="0" sz="2800" spc="-1" strike="noStrike">
               <a:solidFill>
                 <a:srgbClr val="000000"/>
               </a:solidFill>
@@ -1319,7 +1319,7 @@
           <a:bodyPr/>
           <a:p>
             <a:r>
-              <a:rPr lang="en-US"/>
+              <a:rPr/>
               <a:t/>
             </a:r>
           </a:p>
@@ -1375,7 +1375,7 @@
             <a:noAutofit/>
           </a:bodyPr>
           <a:p>
-            <a:endParaRPr b="0" lang="it-IT" sz="1800" spc="-1" strike="noStrike">
+            <a:endParaRPr b="0" sz="1800" spc="-1" strike="noStrike">
               <a:solidFill>
                 <a:srgbClr val="000000"/>
               </a:solidFill>
@@ -1421,7 +1421,7 @@
               </a:spcBef>
               <a:buNone/>
             </a:pPr>
-            <a:endParaRPr b="0" lang="it-IT" sz="2800" spc="-1" strike="noStrike">
+            <a:endParaRPr b="0" sz="2800" spc="-1" strike="noStrike">
               <a:solidFill>
                 <a:srgbClr val="000000"/>
               </a:solidFill>
@@ -1467,7 +1467,7 @@
               </a:spcBef>
               <a:buNone/>
             </a:pPr>
-            <a:endParaRPr b="0" lang="it-IT" sz="2800" spc="-1" strike="noStrike">
+            <a:endParaRPr b="0" sz="2800" spc="-1" strike="noStrike">
               <a:solidFill>
                 <a:srgbClr val="000000"/>
               </a:solidFill>
@@ -1531,7 +1531,7 @@
           <a:bodyPr/>
           <a:p>
             <a:r>
-              <a:rPr lang="en-US"/>
+              <a:rPr/>
               <a:t/>
             </a:r>
           </a:p>
@@ -1587,7 +1587,7 @@
             <a:noAutofit/>
           </a:bodyPr>
           <a:p>
-            <a:endParaRPr b="0" lang="it-IT" sz="1800" spc="-1" strike="noStrike">
+            <a:endParaRPr b="0" sz="1800" spc="-1" strike="noStrike">
               <a:solidFill>
                 <a:srgbClr val="000000"/>
               </a:solidFill>
@@ -1651,7 +1651,7 @@
           <a:bodyPr/>
           <a:p>
             <a:r>
-              <a:rPr lang="en-US"/>
+              <a:rPr/>
               <a:t/>
             </a:r>
           </a:p>
@@ -1710,7 +1710,7 @@
             <a:pPr algn="ctr">
               <a:buNone/>
             </a:pPr>
-            <a:endParaRPr b="0" lang="en-US" sz="3200" spc="-1" strike="noStrike">
+            <a:endParaRPr b="0" sz="3200" spc="-1" strike="noStrike">
               <a:latin typeface="Arial"/>
             </a:endParaRPr>
           </a:p>
@@ -1771,7 +1771,7 @@
           <a:bodyPr/>
           <a:p>
             <a:r>
-              <a:rPr lang="en-US"/>
+              <a:rPr/>
               <a:t/>
             </a:r>
           </a:p>
@@ -1827,7 +1827,7 @@
             <a:noAutofit/>
           </a:bodyPr>
           <a:p>
-            <a:endParaRPr b="0" lang="it-IT" sz="1800" spc="-1" strike="noStrike">
+            <a:endParaRPr b="0" sz="1800" spc="-1" strike="noStrike">
               <a:solidFill>
                 <a:srgbClr val="000000"/>
               </a:solidFill>
@@ -1873,7 +1873,7 @@
               </a:spcBef>
               <a:buNone/>
             </a:pPr>
-            <a:endParaRPr b="0" lang="it-IT" sz="2800" spc="-1" strike="noStrike">
+            <a:endParaRPr b="0" sz="2800" spc="-1" strike="noStrike">
               <a:solidFill>
                 <a:srgbClr val="000000"/>
               </a:solidFill>
@@ -1919,7 +1919,7 @@
               </a:spcBef>
               <a:buNone/>
             </a:pPr>
-            <a:endParaRPr b="0" lang="it-IT" sz="2800" spc="-1" strike="noStrike">
+            <a:endParaRPr b="0" sz="2800" spc="-1" strike="noStrike">
               <a:solidFill>
                 <a:srgbClr val="000000"/>
               </a:solidFill>
@@ -1965,7 +1965,7 @@
               </a:spcBef>
               <a:buNone/>
             </a:pPr>
-            <a:endParaRPr b="0" lang="it-IT" sz="2800" spc="-1" strike="noStrike">
+            <a:endParaRPr b="0" sz="2800" spc="-1" strike="noStrike">
               <a:solidFill>
                 <a:srgbClr val="000000"/>
               </a:solidFill>
@@ -2029,7 +2029,7 @@
           <a:bodyPr/>
           <a:p>
             <a:r>
-              <a:rPr lang="en-US"/>
+              <a:rPr/>
               <a:t/>
             </a:r>
           </a:p>
@@ -2085,7 +2085,7 @@
             <a:noAutofit/>
           </a:bodyPr>
           <a:p>
-            <a:endParaRPr b="0" lang="it-IT" sz="1800" spc="-1" strike="noStrike">
+            <a:endParaRPr b="0" sz="1800" spc="-1" strike="noStrike">
               <a:solidFill>
                 <a:srgbClr val="000000"/>
               </a:solidFill>
@@ -2131,7 +2131,7 @@
               </a:spcBef>
               <a:buNone/>
             </a:pPr>
-            <a:endParaRPr b="0" lang="it-IT" sz="2800" spc="-1" strike="noStrike">
+            <a:endParaRPr b="0" sz="2800" spc="-1" strike="noStrike">
               <a:solidFill>
                 <a:srgbClr val="000000"/>
               </a:solidFill>
@@ -2177,7 +2177,7 @@
               </a:spcBef>
               <a:buNone/>
             </a:pPr>
-            <a:endParaRPr b="0" lang="it-IT" sz="2800" spc="-1" strike="noStrike">
+            <a:endParaRPr b="0" sz="2800" spc="-1" strike="noStrike">
               <a:solidFill>
                 <a:srgbClr val="000000"/>
               </a:solidFill>
@@ -2223,7 +2223,7 @@
               </a:spcBef>
               <a:buNone/>
             </a:pPr>
-            <a:endParaRPr b="0" lang="it-IT" sz="2800" spc="-1" strike="noStrike">
+            <a:endParaRPr b="0" sz="2800" spc="-1" strike="noStrike">
               <a:solidFill>
                 <a:srgbClr val="000000"/>
               </a:solidFill>
@@ -2287,7 +2287,7 @@
           <a:bodyPr/>
           <a:p>
             <a:r>
-              <a:rPr lang="en-US"/>
+              <a:rPr/>
               <a:t/>
             </a:r>
           </a:p>
@@ -2343,7 +2343,7 @@
             <a:noAutofit/>
           </a:bodyPr>
           <a:p>
-            <a:endParaRPr b="0" lang="it-IT" sz="1800" spc="-1" strike="noStrike">
+            <a:endParaRPr b="0" sz="1800" spc="-1" strike="noStrike">
               <a:solidFill>
                 <a:srgbClr val="000000"/>
               </a:solidFill>
@@ -2389,7 +2389,7 @@
               </a:spcBef>
               <a:buNone/>
             </a:pPr>
-            <a:endParaRPr b="0" lang="it-IT" sz="2800" spc="-1" strike="noStrike">
+            <a:endParaRPr b="0" sz="2800" spc="-1" strike="noStrike">
               <a:solidFill>
                 <a:srgbClr val="000000"/>
               </a:solidFill>
@@ -2435,7 +2435,7 @@
               </a:spcBef>
               <a:buNone/>
             </a:pPr>
-            <a:endParaRPr b="0" lang="it-IT" sz="2800" spc="-1" strike="noStrike">
+            <a:endParaRPr b="0" sz="2800" spc="-1" strike="noStrike">
               <a:solidFill>
                 <a:srgbClr val="000000"/>
               </a:solidFill>
@@ -2481,7 +2481,7 @@
               </a:spcBef>
               <a:buNone/>
             </a:pPr>
-            <a:endParaRPr b="0" lang="it-IT" sz="2800" spc="-1" strike="noStrike">
+            <a:endParaRPr b="0" sz="2800" spc="-1" strike="noStrike">
               <a:solidFill>
                 <a:srgbClr val="000000"/>
               </a:solidFill>
@@ -2545,7 +2545,7 @@
           <a:bodyPr/>
           <a:p>
             <a:r>
-              <a:rPr lang="en-US"/>
+              <a:rPr/>
               <a:t/>
             </a:r>
           </a:p>
@@ -2615,7 +2615,7 @@
               <a:buNone/>
             </a:pPr>
             <a:r>
-              <a:rPr b="0" lang="it-IT" sz="6000" spc="-1" strike="noStrike">
+              <a:rPr b="0" sz="6000" spc="-1" strike="noStrike">
                 <a:solidFill>
                   <a:srgbClr val="000000"/>
                 </a:solidFill>
@@ -2623,7 +2623,7 @@
               </a:rPr>
               <a:t>Fare clic per modificare lo stile del titolo dello schema</a:t>
             </a:r>
-            <a:endParaRPr b="0" lang="it-IT" sz="6000" spc="-1" strike="noStrike">
+            <a:endParaRPr b="0" sz="6000" spc="-1" strike="noStrike">
               <a:solidFill>
                 <a:srgbClr val="000000"/>
               </a:solidFill>
@@ -2665,7 +2665,7 @@
                 <a:spcPct val="100000"/>
               </a:lnSpc>
               <a:buNone/>
-              <a:defRPr b="0" lang="it-IT" sz="1200" spc="-1" strike="noStrike">
+              <a:defRPr b="0" sz="1200" spc="-1" strike="noStrike">
                 <a:solidFill>
                   <a:srgbClr val="8b8b8b"/>
                 </a:solidFill>
@@ -2681,7 +2681,7 @@
               <a:buNone/>
             </a:pPr>
             <a:r>
-              <a:rPr b="0" lang="it-IT" sz="1200" spc="-1" strike="noStrike">
+              <a:rPr b="0" sz="1200" spc="-1" strike="noStrike">
                 <a:solidFill>
                   <a:srgbClr val="8b8b8b"/>
                 </a:solidFill>
@@ -2689,7 +2689,7 @@
               </a:rPr>
               <a:t> </a:t>
             </a:r>
-            <a:endParaRPr b="0" lang="en-US" sz="1200" spc="-1" strike="noStrike">
+            <a:endParaRPr b="0" sz="1200" spc="-1" strike="noStrike">
               <a:latin typeface="Times New Roman"/>
             </a:endParaRPr>
           </a:p>
@@ -2725,7 +2725,7 @@
           <a:lstStyle>
             <a:lvl1pPr algn="ctr">
               <a:buNone/>
-              <a:defRPr b="0" lang="en-US" sz="1400" spc="-1" strike="noStrike">
+              <a:defRPr b="0" sz="1400" spc="-1" strike="noStrike">
                 <a:latin typeface="Times New Roman"/>
               </a:defRPr>
             </a:lvl1pPr>
@@ -2735,12 +2735,12 @@
               <a:buNone/>
             </a:pPr>
             <a:r>
-              <a:rPr b="0" lang="en-US" sz="1400" spc="-1" strike="noStrike">
+              <a:rPr b="0" sz="1400" spc="-1" strike="noStrike">
                 <a:latin typeface="Times New Roman"/>
               </a:rPr>
               <a:t>&lt;footer&gt;</a:t>
             </a:r>
-            <a:endParaRPr b="0" lang="en-US" sz="1400" spc="-1" strike="noStrike">
+            <a:endParaRPr b="0" sz="1400" spc="-1" strike="noStrike">
               <a:latin typeface="Times New Roman"/>
             </a:endParaRPr>
           </a:p>
@@ -2779,7 +2779,7 @@
                 <a:spcPct val="100000"/>
               </a:lnSpc>
               <a:buNone/>
-              <a:defRPr b="0" lang="it-IT" sz="1200" spc="-1" strike="noStrike">
+              <a:defRPr b="0" sz="1200" spc="-1" strike="noStrike">
                 <a:solidFill>
                   <a:srgbClr val="8b8b8b"/>
                 </a:solidFill>
@@ -2795,7 +2795,7 @@
               <a:buNone/>
             </a:pPr>
             <a:fld id="{9BEA268E-D5FD-4173-874A-6E43FC1D4BC1}" type="slidenum">
-              <a:rPr b="0" lang="it-IT" sz="1200" spc="-1" strike="noStrike">
+              <a:rPr b="0" sz="1200" spc="-1" strike="noStrike">
                 <a:solidFill>
                   <a:srgbClr val="8b8b8b"/>
                 </a:solidFill>
@@ -2803,7 +2803,7 @@
               </a:rPr>
               <a:t>&lt;number&gt;</a:t>
             </a:fld>
-            <a:endParaRPr b="0" lang="en-US" sz="1200" spc="-1" strike="noStrike">
+            <a:endParaRPr b="0" sz="1200" spc="-1" strike="noStrike">
               <a:latin typeface="Times New Roman"/>
             </a:endParaRPr>
           </a:p>
@@ -2874,7 +2874,7 @@
             <a:noAutofit/>
           </a:bodyPr>
           <a:p>
-            <a:endParaRPr b="0" lang="it-IT" sz="1800" spc="-1" strike="noStrike">
+            <a:endParaRPr b="0" sz="1800" spc="-1" strike="noStrike">
               <a:solidFill>
                 <a:srgbClr val="000000"/>
               </a:solidFill>
@@ -2914,7 +2914,7 @@
             <a:pPr algn="ctr">
               <a:buNone/>
             </a:pPr>
-            <a:endParaRPr b="0" lang="en-US" sz="3200" spc="-1" strike="noStrike">
+            <a:endParaRPr b="0" sz="3200" spc="-1" strike="noStrike">
               <a:latin typeface="Arial"/>
             </a:endParaRPr>
           </a:p>

</xml_diff>

<commit_message>
fix: spellcheck uses passed lang (#114)
</commit_message>
<xml_diff>
--- a/core/src/main/resources/templates/empty.pptx
+++ b/core/src/main/resources/templates/empty.pptx
@@ -84,7 +84,7 @@
           <a:bodyPr/>
           <a:p>
             <a:r>
-              <a:rPr lang="en-US"/>
+              <a:rPr/>
               <a:t/>
             </a:r>
           </a:p>
@@ -140,7 +140,7 @@
             <a:noAutofit/>
           </a:bodyPr>
           <a:p>
-            <a:endParaRPr b="0" lang="it-IT" sz="1800" spc="-1" strike="noStrike">
+            <a:endParaRPr b="0" sz="1800" spc="-1" strike="noStrike">
               <a:solidFill>
                 <a:srgbClr val="000000"/>
               </a:solidFill>
@@ -186,7 +186,7 @@
               </a:spcBef>
               <a:buNone/>
             </a:pPr>
-            <a:endParaRPr b="0" lang="it-IT" sz="2800" spc="-1" strike="noStrike">
+            <a:endParaRPr b="0" sz="2800" spc="-1" strike="noStrike">
               <a:solidFill>
                 <a:srgbClr val="000000"/>
               </a:solidFill>
@@ -232,7 +232,7 @@
               </a:spcBef>
               <a:buNone/>
             </a:pPr>
-            <a:endParaRPr b="0" lang="it-IT" sz="2800" spc="-1" strike="noStrike">
+            <a:endParaRPr b="0" sz="2800" spc="-1" strike="noStrike">
               <a:solidFill>
                 <a:srgbClr val="000000"/>
               </a:solidFill>
@@ -296,7 +296,7 @@
           <a:bodyPr/>
           <a:p>
             <a:r>
-              <a:rPr lang="en-US"/>
+              <a:rPr/>
               <a:t/>
             </a:r>
           </a:p>
@@ -352,7 +352,7 @@
             <a:noAutofit/>
           </a:bodyPr>
           <a:p>
-            <a:endParaRPr b="0" lang="it-IT" sz="1800" spc="-1" strike="noStrike">
+            <a:endParaRPr b="0" sz="1800" spc="-1" strike="noStrike">
               <a:solidFill>
                 <a:srgbClr val="000000"/>
               </a:solidFill>
@@ -398,7 +398,7 @@
               </a:spcBef>
               <a:buNone/>
             </a:pPr>
-            <a:endParaRPr b="0" lang="it-IT" sz="2800" spc="-1" strike="noStrike">
+            <a:endParaRPr b="0" sz="2800" spc="-1" strike="noStrike">
               <a:solidFill>
                 <a:srgbClr val="000000"/>
               </a:solidFill>
@@ -444,7 +444,7 @@
               </a:spcBef>
               <a:buNone/>
             </a:pPr>
-            <a:endParaRPr b="0" lang="it-IT" sz="2800" spc="-1" strike="noStrike">
+            <a:endParaRPr b="0" sz="2800" spc="-1" strike="noStrike">
               <a:solidFill>
                 <a:srgbClr val="000000"/>
               </a:solidFill>
@@ -490,7 +490,7 @@
               </a:spcBef>
               <a:buNone/>
             </a:pPr>
-            <a:endParaRPr b="0" lang="it-IT" sz="2800" spc="-1" strike="noStrike">
+            <a:endParaRPr b="0" sz="2800" spc="-1" strike="noStrike">
               <a:solidFill>
                 <a:srgbClr val="000000"/>
               </a:solidFill>
@@ -536,7 +536,7 @@
               </a:spcBef>
               <a:buNone/>
             </a:pPr>
-            <a:endParaRPr b="0" lang="it-IT" sz="2800" spc="-1" strike="noStrike">
+            <a:endParaRPr b="0" sz="2800" spc="-1" strike="noStrike">
               <a:solidFill>
                 <a:srgbClr val="000000"/>
               </a:solidFill>
@@ -600,7 +600,7 @@
           <a:bodyPr/>
           <a:p>
             <a:r>
-              <a:rPr lang="en-US"/>
+              <a:rPr/>
               <a:t/>
             </a:r>
           </a:p>
@@ -656,7 +656,7 @@
             <a:noAutofit/>
           </a:bodyPr>
           <a:p>
-            <a:endParaRPr b="0" lang="it-IT" sz="1800" spc="-1" strike="noStrike">
+            <a:endParaRPr b="0" sz="1800" spc="-1" strike="noStrike">
               <a:solidFill>
                 <a:srgbClr val="000000"/>
               </a:solidFill>
@@ -702,7 +702,7 @@
               </a:spcBef>
               <a:buNone/>
             </a:pPr>
-            <a:endParaRPr b="0" lang="it-IT" sz="2800" spc="-1" strike="noStrike">
+            <a:endParaRPr b="0" sz="2800" spc="-1" strike="noStrike">
               <a:solidFill>
                 <a:srgbClr val="000000"/>
               </a:solidFill>
@@ -748,7 +748,7 @@
               </a:spcBef>
               <a:buNone/>
             </a:pPr>
-            <a:endParaRPr b="0" lang="it-IT" sz="2800" spc="-1" strike="noStrike">
+            <a:endParaRPr b="0" sz="2800" spc="-1" strike="noStrike">
               <a:solidFill>
                 <a:srgbClr val="000000"/>
               </a:solidFill>
@@ -794,7 +794,7 @@
               </a:spcBef>
               <a:buNone/>
             </a:pPr>
-            <a:endParaRPr b="0" lang="it-IT" sz="2800" spc="-1" strike="noStrike">
+            <a:endParaRPr b="0" sz="2800" spc="-1" strike="noStrike">
               <a:solidFill>
                 <a:srgbClr val="000000"/>
               </a:solidFill>
@@ -840,7 +840,7 @@
               </a:spcBef>
               <a:buNone/>
             </a:pPr>
-            <a:endParaRPr b="0" lang="it-IT" sz="2800" spc="-1" strike="noStrike">
+            <a:endParaRPr b="0" sz="2800" spc="-1" strike="noStrike">
               <a:solidFill>
                 <a:srgbClr val="000000"/>
               </a:solidFill>
@@ -886,7 +886,7 @@
               </a:spcBef>
               <a:buNone/>
             </a:pPr>
-            <a:endParaRPr b="0" lang="it-IT" sz="2800" spc="-1" strike="noStrike">
+            <a:endParaRPr b="0" sz="2800" spc="-1" strike="noStrike">
               <a:solidFill>
                 <a:srgbClr val="000000"/>
               </a:solidFill>
@@ -932,7 +932,7 @@
               </a:spcBef>
               <a:buNone/>
             </a:pPr>
-            <a:endParaRPr b="0" lang="it-IT" sz="2800" spc="-1" strike="noStrike">
+            <a:endParaRPr b="0" sz="2800" spc="-1" strike="noStrike">
               <a:solidFill>
                 <a:srgbClr val="000000"/>
               </a:solidFill>
@@ -996,7 +996,7 @@
           <a:bodyPr/>
           <a:p>
             <a:r>
-              <a:rPr lang="en-US"/>
+              <a:rPr/>
               <a:t/>
             </a:r>
           </a:p>
@@ -1052,7 +1052,7 @@
             <a:noAutofit/>
           </a:bodyPr>
           <a:p>
-            <a:endParaRPr b="0" lang="it-IT" sz="1800" spc="-1" strike="noStrike">
+            <a:endParaRPr b="0" sz="1800" spc="-1" strike="noStrike">
               <a:solidFill>
                 <a:srgbClr val="000000"/>
               </a:solidFill>
@@ -1092,7 +1092,7 @@
             <a:pPr algn="ctr">
               <a:buNone/>
             </a:pPr>
-            <a:endParaRPr b="0" lang="en-US" sz="3200" spc="-1" strike="noStrike">
+            <a:endParaRPr b="0" sz="3200" spc="-1" strike="noStrike">
               <a:latin typeface="Arial"/>
             </a:endParaRPr>
           </a:p>
@@ -1153,7 +1153,7 @@
           <a:bodyPr/>
           <a:p>
             <a:r>
-              <a:rPr lang="en-US"/>
+              <a:rPr/>
               <a:t/>
             </a:r>
           </a:p>
@@ -1209,7 +1209,7 @@
             <a:noAutofit/>
           </a:bodyPr>
           <a:p>
-            <a:endParaRPr b="0" lang="it-IT" sz="1800" spc="-1" strike="noStrike">
+            <a:endParaRPr b="0" sz="1800" spc="-1" strike="noStrike">
               <a:solidFill>
                 <a:srgbClr val="000000"/>
               </a:solidFill>
@@ -1255,7 +1255,7 @@
               </a:spcBef>
               <a:buNone/>
             </a:pPr>
-            <a:endParaRPr b="0" lang="it-IT" sz="2800" spc="-1" strike="noStrike">
+            <a:endParaRPr b="0" sz="2800" spc="-1" strike="noStrike">
               <a:solidFill>
                 <a:srgbClr val="000000"/>
               </a:solidFill>
@@ -1319,7 +1319,7 @@
           <a:bodyPr/>
           <a:p>
             <a:r>
-              <a:rPr lang="en-US"/>
+              <a:rPr/>
               <a:t/>
             </a:r>
           </a:p>
@@ -1375,7 +1375,7 @@
             <a:noAutofit/>
           </a:bodyPr>
           <a:p>
-            <a:endParaRPr b="0" lang="it-IT" sz="1800" spc="-1" strike="noStrike">
+            <a:endParaRPr b="0" sz="1800" spc="-1" strike="noStrike">
               <a:solidFill>
                 <a:srgbClr val="000000"/>
               </a:solidFill>
@@ -1421,7 +1421,7 @@
               </a:spcBef>
               <a:buNone/>
             </a:pPr>
-            <a:endParaRPr b="0" lang="it-IT" sz="2800" spc="-1" strike="noStrike">
+            <a:endParaRPr b="0" sz="2800" spc="-1" strike="noStrike">
               <a:solidFill>
                 <a:srgbClr val="000000"/>
               </a:solidFill>
@@ -1467,7 +1467,7 @@
               </a:spcBef>
               <a:buNone/>
             </a:pPr>
-            <a:endParaRPr b="0" lang="it-IT" sz="2800" spc="-1" strike="noStrike">
+            <a:endParaRPr b="0" sz="2800" spc="-1" strike="noStrike">
               <a:solidFill>
                 <a:srgbClr val="000000"/>
               </a:solidFill>
@@ -1531,7 +1531,7 @@
           <a:bodyPr/>
           <a:p>
             <a:r>
-              <a:rPr lang="en-US"/>
+              <a:rPr/>
               <a:t/>
             </a:r>
           </a:p>
@@ -1587,7 +1587,7 @@
             <a:noAutofit/>
           </a:bodyPr>
           <a:p>
-            <a:endParaRPr b="0" lang="it-IT" sz="1800" spc="-1" strike="noStrike">
+            <a:endParaRPr b="0" sz="1800" spc="-1" strike="noStrike">
               <a:solidFill>
                 <a:srgbClr val="000000"/>
               </a:solidFill>
@@ -1651,7 +1651,7 @@
           <a:bodyPr/>
           <a:p>
             <a:r>
-              <a:rPr lang="en-US"/>
+              <a:rPr/>
               <a:t/>
             </a:r>
           </a:p>
@@ -1710,7 +1710,7 @@
             <a:pPr algn="ctr">
               <a:buNone/>
             </a:pPr>
-            <a:endParaRPr b="0" lang="en-US" sz="3200" spc="-1" strike="noStrike">
+            <a:endParaRPr b="0" sz="3200" spc="-1" strike="noStrike">
               <a:latin typeface="Arial"/>
             </a:endParaRPr>
           </a:p>
@@ -1771,7 +1771,7 @@
           <a:bodyPr/>
           <a:p>
             <a:r>
-              <a:rPr lang="en-US"/>
+              <a:rPr/>
               <a:t/>
             </a:r>
           </a:p>
@@ -1827,7 +1827,7 @@
             <a:noAutofit/>
           </a:bodyPr>
           <a:p>
-            <a:endParaRPr b="0" lang="it-IT" sz="1800" spc="-1" strike="noStrike">
+            <a:endParaRPr b="0" sz="1800" spc="-1" strike="noStrike">
               <a:solidFill>
                 <a:srgbClr val="000000"/>
               </a:solidFill>
@@ -1873,7 +1873,7 @@
               </a:spcBef>
               <a:buNone/>
             </a:pPr>
-            <a:endParaRPr b="0" lang="it-IT" sz="2800" spc="-1" strike="noStrike">
+            <a:endParaRPr b="0" sz="2800" spc="-1" strike="noStrike">
               <a:solidFill>
                 <a:srgbClr val="000000"/>
               </a:solidFill>
@@ -1919,7 +1919,7 @@
               </a:spcBef>
               <a:buNone/>
             </a:pPr>
-            <a:endParaRPr b="0" lang="it-IT" sz="2800" spc="-1" strike="noStrike">
+            <a:endParaRPr b="0" sz="2800" spc="-1" strike="noStrike">
               <a:solidFill>
                 <a:srgbClr val="000000"/>
               </a:solidFill>
@@ -1965,7 +1965,7 @@
               </a:spcBef>
               <a:buNone/>
             </a:pPr>
-            <a:endParaRPr b="0" lang="it-IT" sz="2800" spc="-1" strike="noStrike">
+            <a:endParaRPr b="0" sz="2800" spc="-1" strike="noStrike">
               <a:solidFill>
                 <a:srgbClr val="000000"/>
               </a:solidFill>
@@ -2029,7 +2029,7 @@
           <a:bodyPr/>
           <a:p>
             <a:r>
-              <a:rPr lang="en-US"/>
+              <a:rPr/>
               <a:t/>
             </a:r>
           </a:p>
@@ -2085,7 +2085,7 @@
             <a:noAutofit/>
           </a:bodyPr>
           <a:p>
-            <a:endParaRPr b="0" lang="it-IT" sz="1800" spc="-1" strike="noStrike">
+            <a:endParaRPr b="0" sz="1800" spc="-1" strike="noStrike">
               <a:solidFill>
                 <a:srgbClr val="000000"/>
               </a:solidFill>
@@ -2131,7 +2131,7 @@
               </a:spcBef>
               <a:buNone/>
             </a:pPr>
-            <a:endParaRPr b="0" lang="it-IT" sz="2800" spc="-1" strike="noStrike">
+            <a:endParaRPr b="0" sz="2800" spc="-1" strike="noStrike">
               <a:solidFill>
                 <a:srgbClr val="000000"/>
               </a:solidFill>
@@ -2177,7 +2177,7 @@
               </a:spcBef>
               <a:buNone/>
             </a:pPr>
-            <a:endParaRPr b="0" lang="it-IT" sz="2800" spc="-1" strike="noStrike">
+            <a:endParaRPr b="0" sz="2800" spc="-1" strike="noStrike">
               <a:solidFill>
                 <a:srgbClr val="000000"/>
               </a:solidFill>
@@ -2223,7 +2223,7 @@
               </a:spcBef>
               <a:buNone/>
             </a:pPr>
-            <a:endParaRPr b="0" lang="it-IT" sz="2800" spc="-1" strike="noStrike">
+            <a:endParaRPr b="0" sz="2800" spc="-1" strike="noStrike">
               <a:solidFill>
                 <a:srgbClr val="000000"/>
               </a:solidFill>
@@ -2287,7 +2287,7 @@
           <a:bodyPr/>
           <a:p>
             <a:r>
-              <a:rPr lang="en-US"/>
+              <a:rPr/>
               <a:t/>
             </a:r>
           </a:p>
@@ -2343,7 +2343,7 @@
             <a:noAutofit/>
           </a:bodyPr>
           <a:p>
-            <a:endParaRPr b="0" lang="it-IT" sz="1800" spc="-1" strike="noStrike">
+            <a:endParaRPr b="0" sz="1800" spc="-1" strike="noStrike">
               <a:solidFill>
                 <a:srgbClr val="000000"/>
               </a:solidFill>
@@ -2389,7 +2389,7 @@
               </a:spcBef>
               <a:buNone/>
             </a:pPr>
-            <a:endParaRPr b="0" lang="it-IT" sz="2800" spc="-1" strike="noStrike">
+            <a:endParaRPr b="0" sz="2800" spc="-1" strike="noStrike">
               <a:solidFill>
                 <a:srgbClr val="000000"/>
               </a:solidFill>
@@ -2435,7 +2435,7 @@
               </a:spcBef>
               <a:buNone/>
             </a:pPr>
-            <a:endParaRPr b="0" lang="it-IT" sz="2800" spc="-1" strike="noStrike">
+            <a:endParaRPr b="0" sz="2800" spc="-1" strike="noStrike">
               <a:solidFill>
                 <a:srgbClr val="000000"/>
               </a:solidFill>
@@ -2481,7 +2481,7 @@
               </a:spcBef>
               <a:buNone/>
             </a:pPr>
-            <a:endParaRPr b="0" lang="it-IT" sz="2800" spc="-1" strike="noStrike">
+            <a:endParaRPr b="0" sz="2800" spc="-1" strike="noStrike">
               <a:solidFill>
                 <a:srgbClr val="000000"/>
               </a:solidFill>
@@ -2545,7 +2545,7 @@
           <a:bodyPr/>
           <a:p>
             <a:r>
-              <a:rPr lang="en-US"/>
+              <a:rPr/>
               <a:t/>
             </a:r>
           </a:p>
@@ -2615,7 +2615,7 @@
               <a:buNone/>
             </a:pPr>
             <a:r>
-              <a:rPr b="0" lang="it-IT" sz="6000" spc="-1" strike="noStrike">
+              <a:rPr b="0" sz="6000" spc="-1" strike="noStrike">
                 <a:solidFill>
                   <a:srgbClr val="000000"/>
                 </a:solidFill>
@@ -2623,7 +2623,7 @@
               </a:rPr>
               <a:t>Fare clic per modificare lo stile del titolo dello schema</a:t>
             </a:r>
-            <a:endParaRPr b="0" lang="it-IT" sz="6000" spc="-1" strike="noStrike">
+            <a:endParaRPr b="0" sz="6000" spc="-1" strike="noStrike">
               <a:solidFill>
                 <a:srgbClr val="000000"/>
               </a:solidFill>
@@ -2665,7 +2665,7 @@
                 <a:spcPct val="100000"/>
               </a:lnSpc>
               <a:buNone/>
-              <a:defRPr b="0" lang="it-IT" sz="1200" spc="-1" strike="noStrike">
+              <a:defRPr b="0" sz="1200" spc="-1" strike="noStrike">
                 <a:solidFill>
                   <a:srgbClr val="8b8b8b"/>
                 </a:solidFill>
@@ -2681,7 +2681,7 @@
               <a:buNone/>
             </a:pPr>
             <a:r>
-              <a:rPr b="0" lang="it-IT" sz="1200" spc="-1" strike="noStrike">
+              <a:rPr b="0" sz="1200" spc="-1" strike="noStrike">
                 <a:solidFill>
                   <a:srgbClr val="8b8b8b"/>
                 </a:solidFill>
@@ -2689,7 +2689,7 @@
               </a:rPr>
               <a:t> </a:t>
             </a:r>
-            <a:endParaRPr b="0" lang="en-US" sz="1200" spc="-1" strike="noStrike">
+            <a:endParaRPr b="0" sz="1200" spc="-1" strike="noStrike">
               <a:latin typeface="Times New Roman"/>
             </a:endParaRPr>
           </a:p>
@@ -2725,7 +2725,7 @@
           <a:lstStyle>
             <a:lvl1pPr algn="ctr">
               <a:buNone/>
-              <a:defRPr b="0" lang="en-US" sz="1400" spc="-1" strike="noStrike">
+              <a:defRPr b="0" sz="1400" spc="-1" strike="noStrike">
                 <a:latin typeface="Times New Roman"/>
               </a:defRPr>
             </a:lvl1pPr>
@@ -2735,12 +2735,12 @@
               <a:buNone/>
             </a:pPr>
             <a:r>
-              <a:rPr b="0" lang="en-US" sz="1400" spc="-1" strike="noStrike">
+              <a:rPr b="0" sz="1400" spc="-1" strike="noStrike">
                 <a:latin typeface="Times New Roman"/>
               </a:rPr>
               <a:t>&lt;footer&gt;</a:t>
             </a:r>
-            <a:endParaRPr b="0" lang="en-US" sz="1400" spc="-1" strike="noStrike">
+            <a:endParaRPr b="0" sz="1400" spc="-1" strike="noStrike">
               <a:latin typeface="Times New Roman"/>
             </a:endParaRPr>
           </a:p>
@@ -2779,7 +2779,7 @@
                 <a:spcPct val="100000"/>
               </a:lnSpc>
               <a:buNone/>
-              <a:defRPr b="0" lang="it-IT" sz="1200" spc="-1" strike="noStrike">
+              <a:defRPr b="0" sz="1200" spc="-1" strike="noStrike">
                 <a:solidFill>
                   <a:srgbClr val="8b8b8b"/>
                 </a:solidFill>
@@ -2795,7 +2795,7 @@
               <a:buNone/>
             </a:pPr>
             <a:fld id="{9BEA268E-D5FD-4173-874A-6E43FC1D4BC1}" type="slidenum">
-              <a:rPr b="0" lang="it-IT" sz="1200" spc="-1" strike="noStrike">
+              <a:rPr b="0" sz="1200" spc="-1" strike="noStrike">
                 <a:solidFill>
                   <a:srgbClr val="8b8b8b"/>
                 </a:solidFill>
@@ -2803,7 +2803,7 @@
               </a:rPr>
               <a:t>&lt;number&gt;</a:t>
             </a:fld>
-            <a:endParaRPr b="0" lang="en-US" sz="1200" spc="-1" strike="noStrike">
+            <a:endParaRPr b="0" sz="1200" spc="-1" strike="noStrike">
               <a:latin typeface="Times New Roman"/>
             </a:endParaRPr>
           </a:p>
@@ -2874,7 +2874,7 @@
             <a:noAutofit/>
           </a:bodyPr>
           <a:p>
-            <a:endParaRPr b="0" lang="it-IT" sz="1800" spc="-1" strike="noStrike">
+            <a:endParaRPr b="0" sz="1800" spc="-1" strike="noStrike">
               <a:solidFill>
                 <a:srgbClr val="000000"/>
               </a:solidFill>
@@ -2914,7 +2914,7 @@
             <a:pPr algn="ctr">
               <a:buNone/>
             </a:pPr>
-            <a:endParaRPr b="0" lang="en-US" sz="3200" spc="-1" strike="noStrike">
+            <a:endParaRPr b="0" sz="3200" spc="-1" strike="noStrike">
               <a:latin typeface="Arial"/>
             </a:endParaRPr>
           </a:p>

</xml_diff>